<commit_message>
feat(submissions): revised deck and script after the correctness panel (Phase 6)
A six-seat panel plus a mechanical auditor reviewed the first draft for
correctness only; two gate agents verified 47 of the corrections against
the sources. Applied in one pass: Peirce argued rather than proved the
thesis, the 1892 reply to Kempe as Peirce gave it, CP 1.345 with its own
example, Simmel's distant third kept apart from the lab's majority model,
Loewenheim/Kalmar/Quine stated separately, "every reduction keeps the
junction" with its theorem, Phi and "reduce" defined aloud, and slide 14
citing the pre-registered, tie-robust sample (lab PR #772) instead of the
tie-dependent majority. Records in reviews/2026-09-24/.

Co-Authored-By: Claude Opus 5.5 (1M context) <noreply@anthropic.com>
Claude-Session: https://claude.ai/code/session_01Se7rySQNY9KUjWqpCUhE71
</commit_message>
<xml_diff>
--- a/submissions/triadic_reduction/talk/deck.pptx
+++ b/submissions/triadic_reduction/talk/deck.pptx
@@ -592,38 +592,59 @@
           <a:lstStyle/>
           <a:p>
             <a:r>
-              <a:t>Here is the pattern I want you to see. Kempe added a unit. Peirce, answering him, pointed to "this</a:t>
-            </a:r>
-          </a:p>
-          <a:p>
-            <a:r>
-              <a:t>action", an abstraction added to the universe. Löwenheim added pairs. Quine added sets of the form x, y.</a:t>
-            </a:r>
-          </a:p>
-          <a:p>
-            <a:r>
-              <a:t>Every one of these reductions works by minting a new object that stands for the whole tuple.</a:t>
+              <a:t>Here is what these reductions do. Take "A gives B to C". Mint a new object, g, the giving. Now write three</a:t>
+            </a:r>
+          </a:p>
+          <a:p>
+            <a:r>
+              <a:t>pairs: g's giver is A, g's gift is B, g's recipient is C. Every relation is two-place. But g is a new</a:t>
+            </a:r>
+          </a:p>
+          <a:p>
+            <a:r>
+              <a:t>thing, and it holds the three together. Kempe's unit is that object. So is Peirce's "this action", and so</a:t>
+            </a:r>
+          </a:p>
+          <a:p>
+            <a:r>
+              <a:t>are Löwenheim's and Quine's pairs.</a:t>
             </a:r>
           </a:p>
           <a:p/>
           <a:p>
             <a:r>
-              <a:t>So what the reductions show is this: a relation among three is expressible with two-place relations over</a:t>
-            </a:r>
-          </a:p>
-          <a:p>
-            <a:r>
-              <a:t>a larger universe. What they do not show is that it can be composed from pairs among the same parties.</a:t>
-            </a:r>
-          </a:p>
-          <a:p>
-            <a:r>
-              <a:t>That second claim is the one coordination needs, and Sergiy Koshkin makes the same point about pairing:</a:t>
-            </a:r>
-          </a:p>
-          <a:p>
-            <a:r>
-              <a:t>it conceals the triad; it does not remove it. This slide is my argument, not a consensus.</a:t>
+              <a:t>The logicians made this exact. Hereth Correia and Pöschel proved, and Koshkin has since sharpened, that</a:t>
+            </a:r>
+          </a:p>
+          <a:p>
+            <a:r>
+              <a:t>dyads build a triad only with a three-way junction: a minted object, or a variable shared three ways.</a:t>
+            </a:r>
+          </a:p>
+          <a:p>
+            <a:r>
+              <a:t>Without one, never. Koshkin puts it in logical terms: the pairing construction hides a three-way</a:t>
+            </a:r>
+          </a:p>
+          <a:p>
+            <a:r>
+              <a:t>junction.</a:t>
+            </a:r>
+          </a:p>
+          <a:p/>
+          <a:p>
+            <a:r>
+              <a:t>Why should coordination care about the difference? Because a coordination between two people presupposes</a:t>
+            </a:r>
+          </a:p>
+          <a:p>
+            <a:r>
+              <a:t>that each can act on their own. Fuse them into one unit, or route them through a new object, and you have</a:t>
+            </a:r>
+          </a:p>
+          <a:p>
+            <a:r>
+              <a:t>changed who is coordinating.</a:t>
             </a:r>
           </a:p>
         </p:txBody>
@@ -693,12 +714,22 @@
           <a:lstStyle/>
           <a:p>
             <a:r>
-              <a:t>The logicians after Quine made the disagreement precise. Hans Herzberger showed in 1981 that the thesis holds for one kind of construction and collapses under another. I am relying on Koshkin's account of that paper. Robert Burch built a whole algebra in which it</a:t>
-            </a:r>
-          </a:p>
-          <a:p>
-            <a:r>
-              <a:t>holds. Joachim Hereth Correia and Reinhard Pöschel gave the strongest proofs.</a:t>
+              <a:t>Robert Burch built an algebra, PAL, and proved the thesis in it, but only with a restriction on when</a:t>
+            </a:r>
+          </a:p>
+          <a:p>
+            <a:r>
+              <a:t>products may be formed. Hereth Correia and Pöschel removed the restriction and gave the strongest proofs.</a:t>
+            </a:r>
+          </a:p>
+          <a:p>
+            <a:r>
+              <a:t>Hans Herzberger, in 1981, had shown that the thesis holds for one kind of construction and collapses</a:t>
+            </a:r>
+          </a:p>
+          <a:p>
+            <a:r>
+              <a:t>under another. I am relying on Koshkin's account of that paper.</a:t>
             </a:r>
           </a:p>
           <a:p/>
@@ -719,12 +750,12 @@
           </a:p>
           <a:p>
             <a:r>
-              <a:t>right." Both sides accept the same theorems. They disagree about which constructions are legitimate —</a:t>
-            </a:r>
-          </a:p>
-          <a:p>
-            <a:r>
-              <a:t>and the constructions split, again, on the three-way junction.</a:t>
+              <a:t>right." His view is that if you allow any construction and count each three-way junction as a triad,</a:t>
+            </a:r>
+          </a:p>
+          <a:p>
+            <a:r>
+              <a:t>the thesis comes out true. The split, again, is over the junction.</a:t>
             </a:r>
           </a:p>
         </p:txBody>
@@ -799,33 +830,64 @@
           </a:p>
           <a:p>
             <a:r>
-              <a:t>three, or three things fix one. Causation does say. So we asked the question causally, using integrated</a:t>
-            </a:r>
-          </a:p>
-          <a:p>
-            <a:r>
-              <a:t>information theory, IIT 4.0, as the instrument.</a:t>
+              <a:t>three, or three things fix one. Causation does say. So we asked the question causally, with integrated</a:t>
+            </a:r>
+          </a:p>
+          <a:p>
+            <a:r>
+              <a:t>information theory, IIT 4.0, as the instrument. IIT asks one question of a system: cut it into</a:t>
+            </a:r>
+          </a:p>
+          <a:p>
+            <a:r>
+              <a:t>independent parts, and what do you lose? Φ measures what is lost under the least damaging cut. If Φ is</a:t>
+            </a:r>
+          </a:p>
+          <a:p>
+            <a:r>
+              <a:t>zero, the system splits into parts. If Φ is above zero, every cut loses something.</a:t>
             </a:r>
           </a:p>
           <a:p/>
           <a:p>
             <a:r>
-              <a:t>The criterion, fixed before our confirmatory runs: a genuine triad is a party jointly determined by two</a:t>
-            </a:r>
-          </a:p>
-          <a:p>
-            <a:r>
-              <a:t>others, inside a whole that does not factor. Here is the smallest case. M's next state is A and B</a:t>
-            </a:r>
-          </a:p>
-          <a:p>
-            <a:r>
-              <a:t>together. A and B each read M. IIT finds the whole irreducible, Φ equal to 2.0, with all three in the</a:t>
-            </a:r>
-          </a:p>
-          <a:p>
-            <a:r>
-              <a:t>core. And it finds M's own causes irreducibly spanning A and B. That is joint determination in a whole.</a:t>
+              <a:t>Now the sense of "reduce" I promised. From here on, to reduce a form is to rebuild it among the same</a:t>
+            </a:r>
+          </a:p>
+          <a:p>
+            <a:r>
+              <a:t>parties, out of links in which each element answers to just one other. In Quine's sense, triads reduce.</a:t>
+            </a:r>
+          </a:p>
+          <a:p>
+            <a:r>
+              <a:t>In this sense, the question is open.</a:t>
+            </a:r>
+          </a:p>
+          <a:p/>
+          <a:p>
+            <a:r>
+              <a:t>And the criterion: a genuine triad is a party jointly determined by two others, inside a whole that does</a:t>
+            </a:r>
+          </a:p>
+          <a:p>
+            <a:r>
+              <a:t>not factor. I chose that criterion after our first probes. We then pre-registered a test of it and ran</a:t>
+            </a:r>
+          </a:p>
+          <a:p>
+            <a:r>
+              <a:t>it on new cases. Here is the smallest example; we call it the control. M turns on only when A and B are</a:t>
+            </a:r>
+          </a:p>
+          <a:p>
+            <a:r>
+              <a:t>both on, like a deal that closes only if both sign, and A and B each follow M. Φ is 2.0, with all three in</a:t>
+            </a:r>
+          </a:p>
+          <a:p>
+            <a:r>
+              <a:t>the core. The two arrows into M are not two pairs: M's rule takes A and B together.</a:t>
             </a:r>
           </a:p>
         </p:txBody>
@@ -900,38 +962,43 @@
           </a:p>
           <a:p>
             <a:r>
-              <a:t>other element — the causal version of a dyad — at three and four elements: 89 wirings. We had</a:t>
-            </a:r>
-          </a:p>
-          <a:p>
-            <a:r>
-              <a:t>pre-registered that none would contain a three-party fact. That prediction failed. Branches produced</a:t>
-            </a:r>
-          </a:p>
-          <a:p>
-            <a:r>
-              <a:t>three-party facts.</a:t>
+              <a:t>other element, at three and four elements: 89 wirings. In these models every element, the parties</a:t>
+            </a:r>
+          </a:p>
+          <a:p>
+            <a:r>
+              <a:t>included, answers to one other. We had pre-registered that none would contain a three-party fact. That</a:t>
+            </a:r>
+          </a:p>
+          <a:p>
+            <a:r>
+              <a:t>prediction failed. Branches made three-party facts.</a:t>
             </a:r>
           </a:p>
           <a:p/>
           <a:p>
             <a:r>
-              <a:t>Then we looked at where they sat. Every one was on the effect side: one element fanning out to several.</a:t>
-            </a:r>
-          </a:p>
-          <a:p>
-            <a:r>
-              <a:t>Split the two directions and the cause side never goes above 2. No element is ever jointly determined by</a:t>
-            </a:r>
-          </a:p>
-          <a:p>
-            <a:r>
-              <a:t>two others. I want to be plain about this: that split came after the result, and it is close to true by construction, because a copying element has one cause. What it does is reproduce Peirce's arithmetic in causal</a:t>
-            </a:r>
-          </a:p>
-          <a:p>
-            <a:r>
-              <a:t>terms, with his branch in its place. It is a calibration, not a discovery.</a:t>
+              <a:t>Then we looked at where they sat. Every one was a fan-out: one element read by several. And the systems</a:t>
+            </a:r>
+          </a:p>
+          <a:p>
+            <a:r>
+              <a:t>that had them all split into parts, at Φ equal to zero. On the cause side, a fact never spans more than</a:t>
+            </a:r>
+          </a:p>
+          <a:p>
+            <a:r>
+              <a:t>the element and its one source. No element is ever jointly determined by two others. That split came</a:t>
+            </a:r>
+          </a:p>
+          <a:p>
+            <a:r>
+              <a:t>after the result, and it is close to true by construction, because a copying element has one cause. What</a:t>
+            </a:r>
+          </a:p>
+          <a:p>
+            <a:r>
+              <a:t>it does is reproduce Peirce's arithmetic in causal terms, with his branch in its place.</a:t>
             </a:r>
           </a:p>
         </p:txBody>
@@ -1001,33 +1068,48 @@
           <a:lstStyle/>
           <a:p>
             <a:r>
-              <a:t>The next slide is where the instrument earns its keep, because it separates things the logical debate ran</a:t>
-            </a:r>
-          </a:p>
-          <a:p>
-            <a:r>
-              <a:t>together. A mutual pair, a ring of copies and the imitation of giving are all wholes, at Φ equal to 2.0, and none contains a triad. The control, genuine giving and Peirce's sign with a working interpreter</a:t>
-            </a:r>
-          </a:p>
-          <a:p>
-            <a:r>
-              <a:t>contain joint determination inside a whole. And Simmel's majority has members jointly determined by the</a:t>
-            </a:r>
-          </a:p>
-          <a:p>
-            <a:r>
-              <a:t>other two while the system as a whole factors, at Φ equal to zero. We wrote that prediction down and published it before we ran it.</a:t>
+              <a:t>This is where the instrument earns its keep, because it separates things the logical debate ran together.</a:t>
+            </a:r>
+          </a:p>
+          <a:p>
+            <a:r>
+              <a:t>A mutual pair, a ring of copies and our model of the imitation of giving are all wholes, at Φ equal to</a:t>
+            </a:r>
+          </a:p>
+          <a:p>
+            <a:r>
+              <a:t>2.0. The imitation model closes the loop, because what the receiver holds feeds back to the giver. That</a:t>
+            </a:r>
+          </a:p>
+          <a:p>
+            <a:r>
+              <a:t>return makes it one whole, but no party in it is fixed by two others.</a:t>
             </a:r>
           </a:p>
           <a:p/>
           <a:p>
             <a:r>
-              <a:t>So wholeness and joint determination come apart in both directions. That is why our lab no longer calls</a:t>
-            </a:r>
-          </a:p>
-          <a:p>
-            <a:r>
-              <a:t>every irreducible system triadic. We used to. We now require joint determination as well.</a:t>
+              <a:t>The control, genuine giving, and a model of a sign whose interpretation acts back on its object all have</a:t>
+            </a:r>
+          </a:p>
+          <a:p>
+            <a:r>
+              <a:t>joint determination inside a whole. And in a fresh sample we pre-registered, eleven of thirty forms have</a:t>
+            </a:r>
+          </a:p>
+          <a:p>
+            <a:r>
+              <a:t>a party jointly determined by two others while the system splits into parts. So wholeness and joint</a:t>
+            </a:r>
+          </a:p>
+          <a:p>
+            <a:r>
+              <a:t>determination come apart in both directions. That is why our lab no longer calls every irreducible system</a:t>
+            </a:r>
+          </a:p>
+          <a:p>
+            <a:r>
+              <a:t>triadic. We used to. We now require joint determination as well.</a:t>
             </a:r>
           </a:p>
         </p:txBody>
@@ -1107,55 +1189,65 @@
           </a:p>
           <a:p>
             <a:r>
-              <a:t>loops that chain into a ring, and a ring is a whole with no triad in it.</a:t>
+              <a:t>loops the chain into a ring, and a ring is a whole with no triad in it.</a:t>
             </a:r>
           </a:p>
           <a:p/>
           <a:p>
             <a:r>
-              <a:t>Someone here is about to say: Peirce made every sign triadic, so reading is triadic. Yes. But the sign triad sits inside one reader. It binds the text, what the text is about and one reader's</a:t>
-            </a:r>
-          </a:p>
-          <a:p>
-            <a:r>
-              <a:t>interpretation. It determines nothing on the other person's side. Every sign is triadic. The</a:t>
-            </a:r>
-          </a:p>
-          <a:p>
-            <a:r>
-              <a:t>coordination is a chain.</a:t>
+              <a:t>Someone here is about to say: Peirce made every sign triadic, so reading is triadic. Yes. But the sign</a:t>
+            </a:r>
+          </a:p>
+          <a:p>
+            <a:r>
+              <a:t>triad closes in one reader. It binds the text, what the text is about and one reader's interpretation,</a:t>
+            </a:r>
+          </a:p>
+          <a:p>
+            <a:r>
+              <a:t>and it determines nothing on the other person's side. Every sign is triadic. The coordination is a chain.</a:t>
             </a:r>
           </a:p>
           <a:p/>
           <a:p>
             <a:r>
-              <a:t>Algorithmacy's form is the control. The platform's next state is fixed by both parties at once, and both</a:t>
-            </a:r>
-          </a:p>
-          <a:p>
-            <a:r>
-              <a:t>read it. In that form, when one party acts, what the third does next turns on the other party she cannot</a:t>
-            </a:r>
-          </a:p>
-          <a:p>
-            <a:r>
-              <a:t>see. That is the demand a literate reader never faces.</a:t>
+              <a:t>Algorithmacy's form is the control: a third set by both parties at once, which both then read. A</a:t>
+            </a:r>
+          </a:p>
+          <a:p>
+            <a:r>
+              <a:t>matching platform plausibly has this form. Whether a given platform does depends on its rule, and no one</a:t>
+            </a:r>
+          </a:p>
+          <a:p>
+            <a:r>
+              <a:t>has modelled that yet. In this form, one party's own act settles what the third does only some of the</a:t>
+            </a:r>
+          </a:p>
+          <a:p>
+            <a:r>
+              <a:t>time. Otherwise it turns on the other party's act, so she has to infer the side she cannot see.</a:t>
             </a:r>
           </a:p>
           <a:p/>
           <a:p>
             <a:r>
-              <a:t>I should concede something before you do. Simmel's arbitrator has exactly this form, and there is no</a:t>
-            </a:r>
-          </a:p>
-          <a:p>
-            <a:r>
-              <a:t>algorithm in it. The target is older than AI. What is new is that this form now runs through ordinary</a:t>
-            </a:r>
-          </a:p>
-          <a:p>
-            <a:r>
-              <a:t>work and ordinary life at scale.</a:t>
+              <a:t>I should concede something before you do. Simmel's arbitrator meets this criterion, and there is no</a:t>
+            </a:r>
+          </a:p>
+          <a:p>
+            <a:r>
+              <a:t>algorithm in it. So does a tally that both sides write and both read. The criterion is about form, not</a:t>
+            </a:r>
+          </a:p>
+          <a:p>
+            <a:r>
+              <a:t>about machines. My historical premise, not a lab result, is that this form now runs through ordinary work</a:t>
+            </a:r>
+          </a:p>
+          <a:p>
+            <a:r>
+              <a:t>and ordinary life at scale, mostly through algorithms. That is why I use the name.</a:t>
             </a:r>
           </a:p>
         </p:txBody>
@@ -1225,59 +1317,69 @@
           <a:lstStyle/>
           <a:p>
             <a:r>
-              <a:t>So here is the argument, in the sense of "reduce" I promised to fix. Among fixed parties, one-input</a:t>
-            </a:r>
-          </a:p>
-          <a:p>
-            <a:r>
-              <a:t>mediation never composes joint determination. Joint determination inside a whole exists. So algorithmacy</a:t>
-            </a:r>
-          </a:p>
-          <a:p>
-            <a:r>
-              <a:t>has a target that literacy cannot build out of its own forms.</a:t>
+              <a:t>So here is the argument, in the sense of "reduce" I fixed. Among fixed parties, one-input determination</a:t>
+            </a:r>
+          </a:p>
+          <a:p>
+            <a:r>
+              <a:t>never composes joint determination. Joint determination inside a whole exists. So coordination through a</a:t>
+            </a:r>
+          </a:p>
+          <a:p>
+            <a:r>
+              <a:t>jointly determined third has a target of its own.</a:t>
             </a:r>
           </a:p>
           <a:p/>
           <a:p>
             <a:r>
-              <a:t>That is what I mean by an ontological argument for the necessity of algorithmacy. It is ontological</a:t>
-            </a:r>
-          </a:p>
-          <a:p>
-            <a:r>
-              <a:t>about the target: the kind of coordination exists, and it cannot be composed from literacy's kind. The</a:t>
-            </a:r>
-          </a:p>
-          <a:p>
-            <a:r>
-              <a:t>necessity is conditional: wherever coordination takes this form, the competence it demands is not</a:t>
-            </a:r>
-          </a:p>
-          <a:p>
-            <a:r>
-              <a:t>literacy twice.</a:t>
+              <a:t>One premise carries us from form to competence: to coordinate through such a third, you have to</a:t>
+            </a:r>
+          </a:p>
+          <a:p>
+            <a:r>
+              <a:t>anticipate what it will do, and here that means inferring the party you cannot see. Grant that, and the</a:t>
+            </a:r>
+          </a:p>
+          <a:p>
+            <a:r>
+              <a:t>competence is not literacy twice. That is what I mean by an ontological argument for the necessity of</a:t>
+            </a:r>
+          </a:p>
+          <a:p>
+            <a:r>
+              <a:t>algorithmacy. It is ontological about the target: the kind exists, and literacy's forms cannot compose</a:t>
+            </a:r>
+          </a:p>
+          <a:p>
+            <a:r>
+              <a:t>it. The necessity is conditional: wherever coordination takes this form, the competence it demands is</a:t>
+            </a:r>
+          </a:p>
+          <a:p>
+            <a:r>
+              <a:t>algorithmacy.</a:t>
             </a:r>
           </a:p>
           <a:p/>
           <a:p>
             <a:r>
-              <a:t>Two limits. These are Boolean models, not people; no worker has been measured. And the strongest</a:t>
-            </a:r>
-          </a:p>
-          <a:p>
-            <a:r>
-              <a:t>objection is one Quine would enjoy: you have moved the argument from operations to units, because</a:t>
-            </a:r>
-          </a:p>
-          <a:p>
-            <a:r>
-              <a:t>whether M counts as one party is a choice. IIT has a test for that choice, and running it on this form</a:t>
-            </a:r>
-          </a:p>
-          <a:p>
-            <a:r>
-              <a:t>is our next step. Thank you.</a:t>
+              <a:t>Two limits. These are Boolean models, not people: no worker has been measured and no platform's rule</a:t>
+            </a:r>
+          </a:p>
+          <a:p>
+            <a:r>
+              <a:t>modelled. And the strongest objection is one Quine would enjoy: whether A and B count as separate units</a:t>
+            </a:r>
+          </a:p>
+          <a:p>
+            <a:r>
+              <a:t>is a choice. IIT has its own test for that choice, and running it on this form is our next step. Thank</a:t>
+            </a:r>
+          </a:p>
+          <a:p>
+            <a:r>
+              <a:t>you.</a:t>
             </a:r>
           </a:p>
         </p:txBody>
@@ -1347,17 +1449,22 @@
           <a:lstStyle/>
           <a:p>
             <a:r>
-              <a:t>Here is the worry. Literacy is a competence for working with a medium — a text, a form, a ledger — that</a:t>
-            </a:r>
-          </a:p>
-          <a:p>
-            <a:r>
-              <a:t>answers to one party at a time. Algorithmacy, as I use the word, is a competence for coordinating through</a:t>
-            </a:r>
-          </a:p>
-          <a:p>
-            <a:r>
-              <a:t>a third that both parties determine. The platform that matches a driver and a rider is the obvious case.</a:t>
+              <a:t>Here is the worry. Literacy is a competence for working with a medium that answers to one party at a</a:t>
+            </a:r>
+          </a:p>
+          <a:p>
+            <a:r>
+              <a:t>time: a letter, a notice, a manual. One person fixes it, another reads it. Algorithmacy, as I use the</a:t>
+            </a:r>
+          </a:p>
+          <a:p>
+            <a:r>
+              <a:t>word, is a competence for coordinating through a third that both parties determine, and that acts back</a:t>
+            </a:r>
+          </a:p>
+          <a:p>
+            <a:r>
+              <a:t>on both. A platform that matches a driver and a rider is the picture most of us have in mind.</a:t>
             </a:r>
           </a:p>
           <a:p/>
@@ -1379,12 +1486,12 @@
           </a:p>
           <a:p>
             <a:r>
-              <a:t>hundred and fifty years, and I want to walk through the argument before I say what our lab added to it.</a:t>
-            </a:r>
-          </a:p>
-          <a:p>
-            <a:r>
-              <a:t>One warning in advance: "reduce" is going to need a precise meaning, and by the end I'll have fixed one.</a:t>
+              <a:t>hundred and fifty years, and I want to walk through the argument before I say what our lab added. One</a:t>
+            </a:r>
+          </a:p>
+          <a:p>
+            <a:r>
+              <a:t>warning: "reduce" is going to need a precise meaning, and halfway through I'll fix one.</a:t>
             </a:r>
           </a:p>
         </p:txBody>
@@ -1454,38 +1561,38 @@
           <a:lstStyle/>
           <a:p>
             <a:r>
-              <a:t>The argument starts with Charles Sanders Peirce, and it starts earlier than people usually say. Peirce</a:t>
-            </a:r>
-          </a:p>
-          <a:p>
-            <a:r>
-              <a:t>put both halves of his reduction thesis into a memoir he read in 1870. A relative term cannot be reduced</a:t>
-            </a:r>
-          </a:p>
-          <a:p>
-            <a:r>
-              <a:t>to absolute terms, he wrote, "nor can a conjugative term be reduced to any combination of simple</a:t>
-            </a:r>
-          </a:p>
-          <a:p>
-            <a:r>
-              <a:t>relatives". A conjugative term is a relation among three or more. And every relation among more than</a:t>
-            </a:r>
-          </a:p>
-          <a:p>
-            <a:r>
-              <a:t>two, he said, can be built from relations among three.</a:t>
+              <a:t>The argument starts with Charles Sanders Peirce, and earlier than people usually say. Peirce put both</a:t>
+            </a:r>
+          </a:p>
+          <a:p>
+            <a:r>
+              <a:t>halves of his reduction thesis into a memoir he read in 1870. A relative term cannot be reduced to</a:t>
+            </a:r>
+          </a:p>
+          <a:p>
+            <a:r>
+              <a:t>absolute terms, he wrote, "nor can a conjugative term be reduced to any combination of simple</a:t>
+            </a:r>
+          </a:p>
+          <a:p>
+            <a:r>
+              <a:t>relatives". A conjugative term is a relation among three or more. And every relation among four or</a:t>
+            </a:r>
+          </a:p>
+          <a:p>
+            <a:r>
+              <a:t>more, he said, can be built from relations among three.</a:t>
             </a:r>
           </a:p>
           <a:p/>
           <a:p>
             <a:r>
-              <a:t>Notice what he did not do. He did not prove it. In the same memoir he admits, "I have, however, studied</a:t>
-            </a:r>
-          </a:p>
-          <a:p>
-            <a:r>
-              <a:t>this part of my notation but little." The proof came later, and it came as arithmetic.</a:t>
+              <a:t>Notice what he did not do. He gave no argument for it there. The argument came later, and it came as</a:t>
+            </a:r>
+          </a:p>
+          <a:p>
+            <a:r>
+              <a:t>arithmetic.</a:t>
             </a:r>
           </a:p>
         </p:txBody>
@@ -1560,17 +1667,12 @@
           </a:p>
           <a:p>
             <a:r>
-              <a:t>relations you fill one blank of each with the same thing, so two blanks disappear. Join two dyads and</a:t>
-            </a:r>
-          </a:p>
-          <a:p>
-            <a:r>
-              <a:t>you get two plus two minus two: a dyad again. Join two triads and you get three plus three minus two:</a:t>
-            </a:r>
-          </a:p>
-          <a:p>
-            <a:r>
-              <a:t>four.</a:t>
+              <a:t>relations you fill one blank of each with the same thing, so two blanks disappear. Join two dyads and you</a:t>
+            </a:r>
+          </a:p>
+          <a:p>
+            <a:r>
+              <a:t>get two plus two minus two: a dyad again. Join two triads and you get three plus three minus two: four.</a:t>
             </a:r>
           </a:p>
           <a:p/>
@@ -1581,7 +1683,7 @@
           </a:p>
           <a:p>
             <a:r>
-              <a:t>two stays even, forever. Earlier he gave the picture: "no number of straight roads put end on end will</a:t>
+              <a:t>two stays even, forever. Elsewhere he gave the picture: "no number of straight roads put end on end will</a:t>
             </a:r>
           </a:p>
           <a:p>
@@ -1592,7 +1694,7 @@
           <a:p/>
           <a:p>
             <a:r>
-              <a:t>That is the whole logical argument, and it has one premise hiding in it.</a:t>
+              <a:t>That is the logical argument, and it rests on one premise.</a:t>
             </a:r>
           </a:p>
         </p:txBody>
@@ -1662,48 +1764,43 @@
           <a:lstStyle/>
           <a:p>
             <a:r>
-              <a:t>The hidden premise is about the junction. The arithmetic works only if a point where three lines meet</a:t>
-            </a:r>
-          </a:p>
-          <a:p>
-            <a:r>
-              <a:t>counts as a relation in its own right. Peirce said it does: "every node of bonds is equivalent to a</a:t>
-            </a:r>
-          </a:p>
-          <a:p>
-            <a:r>
-              <a:t>relative".</a:t>
+              <a:t>The premise is about the junction. The arithmetic works only if a point where three lines meet counts as</a:t>
+            </a:r>
+          </a:p>
+          <a:p>
+            <a:r>
+              <a:t>a relation in its own right.</a:t>
             </a:r>
           </a:p>
           <a:p/>
           <a:p>
             <a:r>
-              <a:t>In 1886 Alfred Kempe attacked exactly there. Kempe redrew a triad as an extra unit with three plain links</a:t>
-            </a:r>
-          </a:p>
-          <a:p>
-            <a:r>
-              <a:t>coming off it, so no relation among three appears anywhere. Peirce took the objection seriously. He</a:t>
-            </a:r>
-          </a:p>
-          <a:p>
-            <a:r>
-              <a:t>granted in 1892 that Kempe "virtually shows that my algebra is perfectly adequate to expressing that A</a:t>
-            </a:r>
-          </a:p>
-          <a:p>
-            <a:r>
-              <a:t>gives B to C". What he denied was that expressing a triad this way builds it out of pairs. Kempe's extra</a:t>
-            </a:r>
-          </a:p>
-          <a:p>
-            <a:r>
-              <a:t>unit, he said, is itself the triad. So from its very first round the dispute has been about one thing —</a:t>
-            </a:r>
-          </a:p>
-          <a:p>
-            <a:r>
-              <a:t>the status of the junction.</a:t>
+              <a:t>In 1886 Alfred Kempe challenged the negative clause. He redrew a triad as an extra unit with three plain</a:t>
+            </a:r>
+          </a:p>
+          <a:p>
+            <a:r>
+              <a:t>links coming off it, so that no relation among three appears anywhere. Peirce took the objection</a:t>
+            </a:r>
+          </a:p>
+          <a:p>
+            <a:r>
+              <a:t>seriously. In 1892 he answered that Kempe's picture still contains mediation, in "the attachment of lines</a:t>
+            </a:r>
+          </a:p>
+          <a:p>
+            <a:r>
+              <a:t>to spots", and that the extra unit comes from an abstraction the diagram never shows being made. In 1897</a:t>
+            </a:r>
+          </a:p>
+          <a:p>
+            <a:r>
+              <a:t>he stated the premise outright: "every node of bonds is equivalent to a relative". So from the first</a:t>
+            </a:r>
+          </a:p>
+          <a:p>
+            <a:r>
+              <a:t>round the dispute has been about the junction, and about the object that fills it.</a:t>
             </a:r>
           </a:p>
         </p:txBody>
@@ -1773,23 +1870,23 @@
           <a:lstStyle/>
           <a:p>
             <a:r>
-              <a:t>Peirce's favourite example shows what is at stake. Giving is not two handings. If A puts a book down</a:t>
-            </a:r>
-          </a:p>
-          <a:p>
-            <a:r>
-              <a:t>and C later picks it up, you have, in his words, "merely one dyadic relation followed by another".</a:t>
-            </a:r>
-          </a:p>
-          <a:p>
-            <a:r>
-              <a:t>Genuine giving is "A's making C the possessor according to Law". The three parties are held in one fact.</a:t>
+              <a:t>Peirce's favourite example shows what is at stake. If A throws something away and it happens to hit C,</a:t>
+            </a:r>
+          </a:p>
+          <a:p>
+            <a:r>
+              <a:t>you have, in his words, "merely one dyadic relation followed by another". Genuine giving is "A's making C</a:t>
+            </a:r>
+          </a:p>
+          <a:p>
+            <a:r>
+              <a:t>the possessor according to Law". The three parties are held in one fact.</a:t>
             </a:r>
           </a:p>
           <a:p/>
           <a:p>
             <a:r>
-              <a:t>Keep that pair in mind: the real gift and its imitation. We will meet both again as models.</a:t>
+              <a:t>Keep that pair in mind, the real gift and its imitation. We will meet a model of each.</a:t>
             </a:r>
           </a:p>
         </p:txBody>
@@ -1859,38 +1956,33 @@
           <a:lstStyle/>
           <a:p>
             <a:r>
-              <a:t>That was the logic. Now the sociology. In 1902 Georg Simmel made the same step in the life of groups.</a:t>
-            </a:r>
-          </a:p>
-          <a:p>
-            <a:r>
-              <a:t>In a pair, he wrote, when one member refuses, "only the other remains, without any superindividual</a:t>
-            </a:r>
-          </a:p>
-          <a:p>
-            <a:r>
-              <a:t>energy". Add a third and something new appears: "each pair of elements are now joined by a broken line".</a:t>
-            </a:r>
-          </a:p>
-          <a:p>
-            <a:r>
-              <a:t>A and B are now connected directly and also through C.</a:t>
+              <a:t>That was the logic. Now the sociology. In 1902 Georg Simmel made the same step in the life of groups. In</a:t>
+            </a:r>
+          </a:p>
+          <a:p>
+            <a:r>
+              <a:t>a pair, he wrote, when one member refuses, "only the other remains, without any superindividual energy".</a:t>
+            </a:r>
+          </a:p>
+          <a:p>
+            <a:r>
+              <a:t>Add a third and something new appears: "each pair of elements are now joined by a broken line". A and B</a:t>
+            </a:r>
+          </a:p>
+          <a:p>
+            <a:r>
+              <a:t>are still connected directly, and now also through C, and the same holds for every pair.</a:t>
             </a:r>
           </a:p>
           <a:p/>
           <a:p>
             <a:r>
-              <a:t>Simmel is not arguing about definability. He is describing a change in the form of a group — the</a:t>
-            </a:r>
-          </a:p>
-          <a:p>
-            <a:r>
-              <a:t>mediator, the arbitrator, the third who profits from the quarrel of two. His point is that the step from</a:t>
-            </a:r>
-          </a:p>
-          <a:p>
-            <a:r>
-              <a:t>two to three changes what the group can do.</a:t>
+              <a:t>Simmel is not arguing about definability. He is describing a change in the form of a group: the</a:t>
+            </a:r>
+          </a:p>
+          <a:p>
+            <a:r>
+              <a:t>mediator, the arbitrator, the third who profits from the quarrel of two.</a:t>
             </a:r>
           </a:p>
         </p:txBody>
@@ -1960,33 +2052,28 @@
           <a:lstStyle/>
           <a:p>
             <a:r>
-              <a:t>But Simmel also saw that three people are not automatically a triad. A third who stays distant from the</a:t>
-            </a:r>
-          </a:p>
-          <a:p>
-            <a:r>
-              <a:t>other two leaves, in his translator's phrase, "configurations of twos". The German is</a:t>
-            </a:r>
-          </a:p>
-          <a:p>
-            <a:r>
-              <a:t>Zweierkonfigurationen.</a:t>
+              <a:t>But Simmel also saw that three people are not automatically a triad. He set aside a third so distant</a:t>
+            </a:r>
+          </a:p>
+          <a:p>
+            <a:r>
+              <a:t>from the other two that it unites them only as a pair facing it. There he finds, in his translator's</a:t>
+            </a:r>
+          </a:p>
+          <a:p>
+            <a:r>
+              <a:t>phrase, "configurations of twos". The German is Zweierkonfigurationen.</a:t>
             </a:r>
           </a:p>
           <a:p/>
           <a:p>
             <a:r>
-              <a:t>Our lab tested a version of this. Simmel's majority of three — each member does what the majority does —</a:t>
-            </a:r>
-          </a:p>
-          <a:p>
-            <a:r>
-              <a:t>comes out at Φ equal to zero, with no core. Three parties, and nothing binds them. So the count of three</a:t>
-            </a:r>
-          </a:p>
-          <a:p>
-            <a:r>
-              <a:t>is necessary. It is not sufficient. Hold on to that, because it is the clue to what a genuine triad is.</a:t>
+              <a:t>So three is necessary. It is not sufficient. Hold on to that, because the question of what makes three</a:t>
+            </a:r>
+          </a:p>
+          <a:p>
+            <a:r>
+              <a:t>into one is where our lab comes in.</a:t>
             </a:r>
           </a:p>
         </p:txBody>
@@ -2056,43 +2143,38 @@
           <a:lstStyle/>
           <a:p>
             <a:r>
-              <a:t>Now the reply that made most philosophers stop believing Peirce. In 1915 Leopold Löwenheim showed that</a:t>
-            </a:r>
-          </a:p>
-          <a:p>
-            <a:r>
-              <a:t>you can code any relation as a relation between two things, provided you add new things — pairs — to</a:t>
-            </a:r>
-          </a:p>
-          <a:p>
-            <a:r>
-              <a:t>the universe. In 1936 László Kalmár proved a cousin of the result: for deciding questions of logic, one two-place relation letter is enough. In 1954 W. V. Quine published a two-page paper</a:t>
-            </a:r>
-          </a:p>
-          <a:p>
-            <a:r>
-              <a:t>showing that any theory can be rewritten with "only one predicate letter, and it a dyadic one".</a:t>
+              <a:t>First, though, the result that led many to doubt Peirce, although none of its authors aimed it at him.</a:t>
+            </a:r>
+          </a:p>
+          <a:p>
+            <a:r>
+              <a:t>In 1915 Leopold Löwenheim showed that two-place relations suffice to express any relation, provided you</a:t>
+            </a:r>
+          </a:p>
+          <a:p>
+            <a:r>
+              <a:t>add new objects, pairs, to the domain. In 1936 László Kalmár showed that, for deciding satisfiability,</a:t>
+            </a:r>
+          </a:p>
+          <a:p>
+            <a:r>
+              <a:t>a single two-place relation is enough. And in 1954 W. V. Quine published a short paper showing that any</a:t>
+            </a:r>
+          </a:p>
+          <a:p>
+            <a:r>
+              <a:t>first-order theory can be rewritten with "only one predicate letter, and it a dyadic one".</a:t>
             </a:r>
           </a:p>
           <a:p/>
           <a:p>
             <a:r>
-              <a:t>Two facts about that paper matter. Quine assumes a fragment of set theory, so the pairs are there to</a:t>
-            </a:r>
-          </a:p>
-          <a:p>
-            <a:r>
-              <a:t>use. And on the pages we have checked, he does not mention Peirce at all. The reading of Quine as a</a:t>
-            </a:r>
-          </a:p>
-          <a:p>
-            <a:r>
-              <a:t>refutation of Peirce came from others. Robert Burch reports that the thesis was doubted by many after</a:t>
-            </a:r>
-          </a:p>
-          <a:p>
-            <a:r>
-              <a:t>Quine's proof. Quine himself never said so.</a:t>
+              <a:t>Quine assumes a fragment of set theory, so the pairs are there to use. On the pages we have checked he</a:t>
+            </a:r>
+          </a:p>
+          <a:p>
+            <a:r>
+              <a:t>does not mention Peirce, and Koshkin reports that he never connected the result to Peirce. Others did.</a:t>
             </a:r>
           </a:p>
         </p:txBody>
@@ -5260,7 +5342,7 @@
                 </a:solidFill>
                 <a:latin typeface="Arial"/>
               </a:rPr>
-              <a:t>Every reduction mints a third</a:t>
+              <a:t>Every reduction keeps the junction</a:t>
             </a:r>
           </a:p>
         </p:txBody>
@@ -5299,7 +5381,7 @@
                 </a:solidFill>
                 <a:latin typeface="Arial"/>
               </a:rPr>
-              <a:t>Kempe: a unit · Peirce: "this action" · Löwenheim: pairs · Quine: {x, y}</a:t>
+              <a:t>"A gives B to C" → mint g, the giving: giver(g, A) · gift(g, B) · recipient(g, C)</a:t>
             </a:r>
           </a:p>
           <a:p>
@@ -5315,7 +5397,39 @@
                 </a:solidFill>
                 <a:latin typeface="Arial"/>
               </a:rPr>
-              <a:t>Expressible over a larger universe ≠ composed from pairs among the same parties</a:t>
+              <a:t>Kempe: a unit · Peirce: "this action" · Löwenheim and Quine: pairs</a:t>
+            </a:r>
+          </a:p>
+          <a:p>
+            <a:pPr algn="l">
+              <a:spcBef>
+                <a:spcPts val="1400"/>
+              </a:spcBef>
+            </a:pPr>
+            <a:r>
+              <a:rPr sz="2400" b="0" i="0">
+                <a:solidFill>
+                  <a:srgbClr val="000000"/>
+                </a:solidFill>
+                <a:latin typeface="Arial"/>
+              </a:rPr>
+              <a:t>Dyads build a triad only with a three-way junction. Without one, never.</a:t>
+            </a:r>
+          </a:p>
+          <a:p>
+            <a:pPr algn="l">
+              <a:spcBef>
+                <a:spcPts val="1400"/>
+              </a:spcBef>
+            </a:pPr>
+            <a:r>
+              <a:rPr sz="1800" b="0" i="0">
+                <a:solidFill>
+                  <a:srgbClr val="000000"/>
+                </a:solidFill>
+                <a:latin typeface="Arial"/>
+              </a:rPr>
+              <a:t>— Hereth Correia &amp; Pöschel 2006; Koshkin 2025</a:t>
             </a:r>
           </a:p>
         </p:txBody>
@@ -5581,13 +5695,29 @@
               </a:spcBef>
             </a:pPr>
             <a:r>
+              <a:rPr sz="2400" b="0" i="0">
+                <a:solidFill>
+                  <a:srgbClr val="000000"/>
+                </a:solidFill>
+                <a:latin typeface="Arial"/>
+              </a:rPr>
+              <a:t>Φ: what a system loses under its weakest cut (IIT 4.0). Φ = 0: it splits into parts.</a:t>
+            </a:r>
+          </a:p>
+          <a:p>
+            <a:pPr algn="l">
+              <a:spcBef>
+                <a:spcPts val="1400"/>
+              </a:spcBef>
+            </a:pPr>
+            <a:r>
               <a:rPr sz="2200" b="0" i="0">
                 <a:solidFill>
                   <a:srgbClr val="000000"/>
                 </a:solidFill>
                 <a:latin typeface="Courier New"/>
               </a:rPr>
-              <a:t>A → M ← B      M′ = A and B;  A′ = M;  B′ = M</a:t>
+              <a:t>A &lt;-&gt; M &lt;-&gt; B     M' = A and B;  A' = M;  B' = M</a:t>
             </a:r>
           </a:p>
           <a:p>
@@ -5603,7 +5733,7 @@
                 </a:solidFill>
                 <a:latin typeface="Courier New"/>
               </a:rPr>
-              <a:t>Φ = 2.0   core {A, M, B}</a:t>
+              <a:t>Φ = 2.0   all three in the core   "the control"</a:t>
             </a:r>
           </a:p>
         </p:txBody>
@@ -5707,7 +5837,7 @@
                 </a:solidFill>
                 <a:latin typeface="Arial"/>
               </a:rPr>
-              <a:t>89 one-input wirings: pre-registered H1 REFUTED</a:t>
+              <a:t>89 one-input wirings: pre-registered H1 REFUTED — branches make three-party facts</a:t>
             </a:r>
           </a:p>
           <a:p>
@@ -5723,7 +5853,7 @@
                 </a:solidFill>
                 <a:latin typeface="Arial"/>
               </a:rPr>
-              <a:t>Split afterwards: cause side never above 2</a:t>
+              <a:t>Every three-party fact is a fan-out: one element read by several</a:t>
             </a:r>
           </a:p>
           <a:p>
@@ -5739,7 +5869,7 @@
                 </a:solidFill>
                 <a:latin typeface="Arial"/>
               </a:rPr>
-              <a:t>Every excess on the effect side — the branch</a:t>
+              <a:t>On the cause side: the element plus its one source, never more</a:t>
             </a:r>
           </a:p>
         </p:txBody>
@@ -5843,7 +5973,7 @@
                 </a:solidFill>
                 <a:latin typeface="Arial"/>
               </a:rPr>
-              <a:t>Wholes with no triad: mutual dyad, copy ring, imitation of giving — Φ = 2.0</a:t>
+              <a:t>Wholes, no joint determination: mutual pair, ring of copies, imitation of giving — Φ = 2.0</a:t>
             </a:r>
           </a:p>
           <a:p>
@@ -5859,7 +5989,7 @@
                 </a:solidFill>
                 <a:latin typeface="Arial"/>
               </a:rPr>
-              <a:t>Joint determination in a whole: the control, genuine giving, the pragmatic sign</a:t>
+              <a:t>Joint determination in a whole: the control, genuine giving, a sign that acts back on its object</a:t>
             </a:r>
           </a:p>
           <a:p>
@@ -5875,7 +6005,7 @@
                 </a:solidFill>
                 <a:latin typeface="Arial"/>
               </a:rPr>
-              <a:t>Joint determination without a whole: Simmel's majority — Φ = 0</a:t>
+              <a:t>Joint determination, no whole: 11 of 30 fresh forms (pre-registered)</a:t>
             </a:r>
           </a:p>
         </p:txBody>
@@ -5995,7 +6125,7 @@
                 </a:solidFill>
                 <a:latin typeface="Arial"/>
               </a:rPr>
-              <a:t>Algorithmacy: A → M ← B, M read by both — a whole</a:t>
+              <a:t>Algorithmacy: A &lt;-&gt; M &lt;-&gt; B, M set by both at once — a whole</a:t>
             </a:r>
           </a:p>
           <a:p>
@@ -6027,7 +6157,7 @@
                 </a:solidFill>
                 <a:latin typeface="Arial"/>
               </a:rPr>
-              <a:t>The target is older than AI: Simmel's arbitrator has the same form.</a:t>
+              <a:t>Older than AI: Simmel's arbitrator, a shared tally, meet the same criterion.</a:t>
             </a:r>
           </a:p>
         </p:txBody>
@@ -6131,7 +6261,7 @@
                 </a:solidFill>
                 <a:latin typeface="Arial"/>
               </a:rPr>
-              <a:t>Among fixed parties, one-input mediation never composes joint determination.</a:t>
+              <a:t>Among fixed parties, one-input determination never composes joint determination.</a:t>
             </a:r>
           </a:p>
           <a:p>
@@ -6163,7 +6293,7 @@
                 </a:solidFill>
                 <a:latin typeface="Arial"/>
               </a:rPr>
-              <a:t>So algorithmacy has a target of its own.</a:t>
+              <a:t>So coordination through a jointly determined third has a target of its own.</a:t>
             </a:r>
           </a:p>
           <a:p>
@@ -6179,7 +6309,7 @@
                 </a:solidFill>
                 <a:latin typeface="Arial"/>
               </a:rPr>
-              <a:t>Boolean models, not people.</a:t>
+              <a:t>Boolean models, not people. No platform's rule modelled.</a:t>
             </a:r>
           </a:p>
         </p:txBody>
@@ -6283,7 +6413,7 @@
                 </a:solidFill>
                 <a:latin typeface="Arial"/>
               </a:rPr>
-              <a:t>Literacy: a medium that answers to one party at a time.</a:t>
+              <a:t>Literacy: a medium that answers to one party at a time — a letter, a notice, a manual.</a:t>
             </a:r>
           </a:p>
           <a:p>
@@ -6299,7 +6429,7 @@
                 </a:solidFill>
                 <a:latin typeface="Arial"/>
               </a:rPr>
-              <a:t>Algorithmacy: a third that both parties determine.</a:t>
+              <a:t>Algorithmacy: a third that both parties determine, and that acts back on both.</a:t>
             </a:r>
           </a:p>
           <a:p>
@@ -6315,7 +6445,7 @@
                 </a:solidFill>
                 <a:latin typeface="Arial"/>
               </a:rPr>
-              <a:t>Do some triads resist reduction — in the sense that matters for coordination?</a:t>
+              <a:t>Do some triads resist reduction, in the sense that matters for coordination?</a:t>
             </a:r>
           </a:p>
         </p:txBody>
@@ -6445,13 +6575,29 @@
               </a:spcBef>
             </a:pPr>
             <a:r>
-              <a:rPr sz="2400" b="0" i="1">
+              <a:rPr sz="2400" b="0" i="0">
                 <a:solidFill>
                   <a:srgbClr val="000000"/>
                 </a:solidFill>
                 <a:latin typeface="Arial"/>
               </a:rPr>
-              <a:t>I have, however, studied this part of my notation but little.</a:t>
+              <a:t>Every relation among four or more: built from relations among three.</a:t>
+            </a:r>
+          </a:p>
+          <a:p>
+            <a:pPr algn="l">
+              <a:spcBef>
+                <a:spcPts val="1400"/>
+              </a:spcBef>
+            </a:pPr>
+            <a:r>
+              <a:rPr sz="2400" b="0" i="0">
+                <a:solidFill>
+                  <a:srgbClr val="000000"/>
+                </a:solidFill>
+                <a:latin typeface="Arial"/>
+              </a:rPr>
+              <a:t>Asserted, not yet argued.</a:t>
             </a:r>
           </a:p>
         </p:txBody>
@@ -6733,13 +6879,13 @@
               </a:spcBef>
             </a:pPr>
             <a:r>
-              <a:rPr sz="2400" b="0" i="1">
+              <a:rPr sz="2400" b="0" i="0">
                 <a:solidFill>
                   <a:srgbClr val="000000"/>
                 </a:solidFill>
                 <a:latin typeface="Arial"/>
               </a:rPr>
-              <a:t>every node of bonds is equivalent to a relative</a:t>
+              <a:t>Kempe, 1886: a triad = a unit plus three links. No relation among three.</a:t>
             </a:r>
           </a:p>
           <a:p>
@@ -6749,13 +6895,13 @@
               </a:spcBef>
             </a:pPr>
             <a:r>
-              <a:rPr sz="1800" b="0" i="0">
+              <a:rPr sz="2400" b="0" i="0">
                 <a:solidFill>
                   <a:srgbClr val="000000"/>
                 </a:solidFill>
                 <a:latin typeface="Arial"/>
               </a:rPr>
-              <a:t>— Peirce, 1897</a:t>
+              <a:t>Peirce, 1892: mediation is still there, in "the attachment of lines to spots"</a:t>
             </a:r>
           </a:p>
           <a:p>
@@ -6771,23 +6917,7 @@
                 </a:solidFill>
                 <a:latin typeface="Arial"/>
               </a:rPr>
-              <a:t>Kempe, 1886: a triad = a unit plus three links.</a:t>
-            </a:r>
-          </a:p>
-          <a:p>
-            <a:pPr algn="l">
-              <a:spcBef>
-                <a:spcPts val="1400"/>
-              </a:spcBef>
-            </a:pPr>
-            <a:r>
-              <a:rPr sz="2400" b="0" i="0">
-                <a:solidFill>
-                  <a:srgbClr val="000000"/>
-                </a:solidFill>
-                <a:latin typeface="Arial"/>
-              </a:rPr>
-              <a:t>Peirce, 1892: Kempe "virtually shows that my algebra is perfectly adequate to expressing that A gives B to C"</a:t>
+              <a:t>Peirce, 1897: "every node of bonds is equivalent to a relative"</a:t>
             </a:r>
           </a:p>
         </p:txBody>
@@ -6852,7 +6982,7 @@
                 </a:solidFill>
                 <a:latin typeface="Arial"/>
               </a:rPr>
-              <a:t>Giving is one fact, not two handings</a:t>
+              <a:t>Giving is one fact, not two events</a:t>
             </a:r>
           </a:p>
         </p:txBody>
@@ -6907,7 +7037,7 @@
                 </a:solidFill>
                 <a:latin typeface="Arial"/>
               </a:rPr>
-              <a:t>Imitation: "merely one dyadic relation followed by another" (CP 1.345)</a:t>
+              <a:t>Imitation: A throws B away and it happens to hit C — "merely one dyadic relation followed by another" (CP 1.345)</a:t>
             </a:r>
           </a:p>
         </p:txBody>
@@ -7043,7 +7173,23 @@
                 </a:solidFill>
                 <a:latin typeface="Courier New"/>
               </a:rPr>
-              <a:t>A — C — B</a:t>
+              <a:t>A ——— B   directly</a:t>
+            </a:r>
+          </a:p>
+          <a:p>
+            <a:pPr algn="l">
+              <a:spcBef>
+                <a:spcPts val="0"/>
+              </a:spcBef>
+            </a:pPr>
+            <a:r>
+              <a:rPr sz="2200" b="0" i="0">
+                <a:solidFill>
+                  <a:srgbClr val="000000"/>
+                </a:solidFill>
+                <a:latin typeface="Courier New"/>
+              </a:rPr>
+              <a:t>A — C — B also, for every pair</a:t>
             </a:r>
           </a:p>
           <a:p>
@@ -7163,7 +7309,7 @@
                 </a:solidFill>
                 <a:latin typeface="Arial"/>
               </a:rPr>
-              <a:t>A distant third leaves "configurations of twos" (Simmel, 1902; 1908)</a:t>
+              <a:t>A third too distant from the other two leaves "configurations of twos"</a:t>
             </a:r>
           </a:p>
           <a:p>
@@ -7173,13 +7319,29 @@
               </a:spcBef>
             </a:pPr>
             <a:r>
-              <a:rPr sz="2400" b="0" i="0">
+              <a:rPr sz="1800" b="0" i="0">
                 <a:solidFill>
                   <a:srgbClr val="000000"/>
                 </a:solidFill>
                 <a:latin typeface="Arial"/>
               </a:rPr>
-              <a:t>Lab, Simmel's majority of three: Φ = 0, no core.</a:t>
+              <a:t>— Simmel, 1902 (Zweierkonfigurationen, 1908)</a:t>
+            </a:r>
+          </a:p>
+          <a:p>
+            <a:pPr algn="l">
+              <a:spcBef>
+                <a:spcPts val="1400"/>
+              </a:spcBef>
+            </a:pPr>
+            <a:r>
+              <a:rPr sz="2400" b="0" i="0">
+                <a:solidFill>
+                  <a:srgbClr val="000000"/>
+                </a:solidFill>
+                <a:latin typeface="Arial"/>
+              </a:rPr>
+              <a:t>Three is necessary. It is not sufficient.</a:t>
             </a:r>
           </a:p>
         </p:txBody>
@@ -7244,7 +7406,7 @@
                 </a:solidFill>
                 <a:latin typeface="Arial"/>
               </a:rPr>
-              <a:t>One dyadic predicate for everything</a:t>
+              <a:t>Dyadic predicates suffice — with new objects</a:t>
             </a:r>
           </a:p>
         </p:txBody>
@@ -7283,7 +7445,7 @@
                 </a:solidFill>
                 <a:latin typeface="Arial"/>
               </a:rPr>
-              <a:t>Löwenheim 1915 · Kalmár 1936 · Quine 1954</a:t>
+              <a:t>Löwenheim 1915: binary relatives suffice, over a domain of pairs</a:t>
             </a:r>
           </a:p>
           <a:p>
@@ -7299,7 +7461,7 @@
                 </a:solidFill>
                 <a:latin typeface="Arial"/>
               </a:rPr>
-              <a:t>A theory with "only one predicate letter, and it a dyadic one"</a:t>
+              <a:t>Kalmár 1936: one binary relation, for deciding satisfiability</a:t>
             </a:r>
           </a:p>
           <a:p>
@@ -7315,7 +7477,23 @@
                 </a:solidFill>
                 <a:latin typeface="Arial"/>
               </a:rPr>
-              <a:t>Quine does not name Peirce on the pages read.</a:t>
+              <a:t>Quine 1954: any first-order theory, with "only one predicate letter, and it a dyadic one"</a:t>
+            </a:r>
+          </a:p>
+          <a:p>
+            <a:pPr algn="l">
+              <a:spcBef>
+                <a:spcPts val="1400"/>
+              </a:spcBef>
+            </a:pPr>
+            <a:r>
+              <a:rPr sz="2400" b="0" i="0">
+                <a:solidFill>
+                  <a:srgbClr val="000000"/>
+                </a:solidFill>
+                <a:latin typeface="Arial"/>
+              </a:rPr>
+              <a:t>None of them aimed it at Peirce.</a:t>
             </a:r>
           </a:p>
         </p:txBody>

</xml_diff>

<commit_message>
fix(submissions): apply the author-approved slide 13-14 corrections
Slide 13 becomes "The Causal Test (IIT 4.0)". It keeps the author's
scissors reading of Φ = 0 and Φ > 0 and adds that a ring of one-input
copies is a whole at Φ = 2.0. The "Causal Collapse Theorem" is gone.
The lab refutes it (copy_BCA, dyad_mutual).

Slide 14's table now matches the record. Φ > 0 in 8 of the 89 wirings,
the ring is one of the 89, and "synergy" becomes "triad", since no run
measured synergy. Row 4 is Φ > 0, a range of 0.21-2.0. The script drops
the PID sentence and discloses that the pre-registered H1 was refuted
and that the cause-side reading is post hoc.

Three sentences in the Claude-drafted slides 18-19 are shortened to keep
the script inside the 30-minute budget. check_talk: 23 slides, 0 problems.

Co-Authored-By: Claude Opus 5.5 <noreply@anthropic.com>
Claude-Session: https://claude.ai/code/session_01639fCrE2nftVEVD5CsfTAE
</commit_message>
<xml_diff>
--- a/submissions/triadic_reduction/talk/deck.pptx
+++ b/submissions/triadic_reduction/talk/deck.pptx
@@ -1013,7 +1013,7 @@
           </a:p>
           <a:p>
             <a:r>
-              <a:t>An **irreducible triad** is a mechanism jointly determined by two other elements, with all three belonging to an integrated complex ($\Phi &gt; 0$). In our minimal control circuit ($M' = A \land B$; $A' = M$; $B' = M$), IIT 4.0 yields $\Phi = 2.0$, with all three nodes in the core complex. Under Partial Information Decomposition (PID), this configuration exhibits pure causal synergy ($\text{Syn} &gt; 0$).</a:t>
+              <a:t>An **irreducible triad** is a mechanism jointly determined by two other elements, with all three belonging to an integrated complex ($\Phi &gt; 0$). In our minimal control circuit ($M' = A \land B$; $A' = M$; $B' = M$), IIT 4.0 yields $\Phi = 2.0$, with all three nodes in the core complex.</a:t>
             </a:r>
           </a:p>
           <a:p/>
@@ -1025,7 +1025,7 @@
           <a:p/>
           <a:p>
             <a:r>
-              <a:t>1. **Dyadic Wirings Conserve Dyads:** Testing 89 discrete single-input copy architectures confirms Peirce's valency rule: pairwise connections produce only pairwise distinctions, generating zero triadic mechanisms.</a:t>
+              <a:t>1. **Dyadic Wirings Conserve Dyads:** Testing 89 discrete single-input copy architectures, no element is ever determined by two others: pairwise connections produce only pairwise determination. Our pre-registered hypothesis was refuted on the effect side, where one element can drive three; the cause-side reading is post hoc.</a:t>
             </a:r>
           </a:p>
           <a:p/>
@@ -1421,7 +1421,7 @@
           </a:p>
           <a:p>
             <a:r>
-              <a:t>The dealer only relays: let the maker sell direct and Φ falls from 2.0 to 0.0. The clearinghouse keeps 2.0 under the same bypass. The brokerage types sort the same way, on constructed forms, not fitted markets.</a:t>
+              <a:t>The dealer only relays: let the maker sell direct and Φ falls from 2.0 to 0.0. The clearinghouse keeps 2.0 under the same bypass. The brokerage types sort the same way. These are constructed forms, not markets.</a:t>
             </a:r>
           </a:p>
           <a:p/>
@@ -1432,7 +1432,7 @@
           </a:p>
           <a:p>
             <a:r>
-              <a:t>A toll booth on the only bridge matters until a second bridge goes up. A translator between two people with no common language matters whatever you build. Our test builds the second bridge and asks who is still needed.</a:t>
+              <a:t>A toll booth on the only bridge matters until a second bridge goes up. A translator between strangers matters whatever you build. Our test builds the second bridge and asks who is still needed.</a:t>
             </a:r>
           </a:p>
         </p:txBody>
@@ -1518,7 +1518,7 @@
           </a:p>
           <a:p>
             <a:r>
-              <a:t>A kitchen with the recipes written down. Check the oven on a dish you know, then cook your own. Write down what you expect before you taste. A dish that comes out wrong still goes in the book.</a:t>
+              <a:t>A kitchen with the recipes written down. Check the oven on a dish you know, then cook your own. Write down what you expect before you taste. A failed dish still goes in the book.</a:t>
             </a:r>
           </a:p>
         </p:txBody>
@@ -6676,7 +6676,7 @@
                 </a:solidFill>
                 <a:latin typeface="Arial"/>
               </a:rPr>
-              <a:t>Causal Collapse Theorem (IIT 4.0)</a:t>
+              <a:t>The Causal Test (IIT 4.0)</a:t>
             </a:r>
           </a:p>
         </p:txBody>
@@ -6717,6 +6717,15 @@
               </a:rPr>
               <a:t>Φ = 0</a:t>
             </a:r>
+            <a:r>
+              <a:rPr sz="2200" b="0" i="0">
+                <a:solidFill>
+                  <a:srgbClr val="000000"/>
+                </a:solidFill>
+                <a:latin typeface="Arial"/>
+              </a:rPr>
+              <a:t> — the system factors: cutting its weakest seam loses nothing.</a:t>
+            </a:r>
           </a:p>
           <a:p>
             <a:pPr algn="l">
@@ -6731,7 +6740,32 @@
                 </a:solidFill>
                 <a:latin typeface="Arial"/>
               </a:rPr>
-              <a:t>Extensional Dyadic Decomposition Erases System Synergy</a:t>
+              <a:t>Φ &gt; 0</a:t>
+            </a:r>
+            <a:r>
+              <a:rPr sz="2200" b="0" i="0">
+                <a:solidFill>
+                  <a:srgbClr val="000000"/>
+                </a:solidFill>
+                <a:latin typeface="Arial"/>
+              </a:rPr>
+              <a:t> — the system is a whole: no cut leaves it as it was.</a:t>
+            </a:r>
+          </a:p>
+          <a:p>
+            <a:pPr algn="l">
+              <a:spcBef>
+                <a:spcPts val="1600"/>
+              </a:spcBef>
+            </a:pPr>
+            <a:r>
+              <a:rPr sz="2200" b="1" i="0">
+                <a:solidFill>
+                  <a:srgbClr val="000000"/>
+                </a:solidFill>
+                <a:latin typeface="Arial"/>
+              </a:rPr>
+              <a:t>Wholeness Is Not Yet a Triad</a:t>
             </a:r>
           </a:p>
           <a:p>
@@ -6747,23 +6781,7 @@
                 </a:solidFill>
                 <a:latin typeface="Arial"/>
               </a:rPr>
-              <a:t>Forcing multi-input causal mechanisms into dyadic channels matches the partitioned repertoire with the whole.</a:t>
-            </a:r>
-          </a:p>
-          <a:p>
-            <a:pPr algn="l">
-              <a:spcBef>
-                <a:spcPts val="400"/>
-              </a:spcBef>
-            </a:pPr>
-            <a:r>
-              <a:rPr sz="2200" b="0" i="0">
-                <a:solidFill>
-                  <a:srgbClr val="000000"/>
-                </a:solidFill>
-                <a:latin typeface="Arial"/>
-              </a:rPr>
-              <a:t>Integrated information vanishes under the Minimum Information Partition (MIP).</a:t>
+              <a:t>Φ says whether the system factors, not whether any member is set by two others. A ring of one-input copies is a whole at Φ = 2.0.</a:t>
             </a:r>
           </a:p>
         </p:txBody>
@@ -7232,7 +7250,7 @@
                           </a:solidFill>
                           <a:latin typeface="Arial"/>
                         </a:rPr>
-                        <a:t>Φ = 0.0</a:t>
+                        <a:t>Φ &gt; 0 in 8</a:t>
                       </a:r>
                     </a:p>
                   </a:txBody>
@@ -7272,7 +7290,7 @@
                           </a:solidFill>
                           <a:latin typeface="Arial"/>
                         </a:rPr>
-                        <a:t>No Complex</a:t>
+                        <a:t>No Member Set by Two Others</a:t>
                       </a:r>
                     </a:p>
                   </a:txBody>
@@ -7354,7 +7372,7 @@
                           </a:solidFill>
                           <a:latin typeface="Arial"/>
                         </a:rPr>
-                        <a:t>Feedback Loop</a:t>
+                        <a:t>One of the 89</a:t>
                       </a:r>
                     </a:p>
                   </a:txBody>
@@ -7474,7 +7492,7 @@
                           </a:solidFill>
                           <a:latin typeface="Arial"/>
                         </a:rPr>
-                        <a:t>Whole Without Synergy</a:t>
+                        <a:t>Whole Without a Triad</a:t>
                       </a:r>
                     </a:p>
                   </a:txBody>
@@ -7596,7 +7614,7 @@
                           </a:solidFill>
                           <a:latin typeface="Arial"/>
                         </a:rPr>
-                        <a:t>Synergistic gate</a:t>
+                        <a:t>Two-input gate</a:t>
                       </a:r>
                     </a:p>
                   </a:txBody>
@@ -7676,7 +7694,7 @@
                           </a:solidFill>
                           <a:latin typeface="Arial"/>
                         </a:rPr>
-                        <a:t>Synergy Without Whole</a:t>
+                        <a:t>Triad Without a Whole</a:t>
                       </a:r>
                     </a:p>
                   </a:txBody>
@@ -7798,7 +7816,7 @@
                           </a:solidFill>
                           <a:latin typeface="Arial"/>
                         </a:rPr>
-                        <a:t>Teridentity in loop</a:t>
+                        <a:t>Two-input gate in the loop</a:t>
                       </a:r>
                     </a:p>
                   </a:txBody>
@@ -7838,7 +7856,7 @@
                           </a:solidFill>
                           <a:latin typeface="Arial"/>
                         </a:rPr>
-                        <a:t>Φ = 2.0</a:t>
+                        <a:t>Φ &gt; 0</a:t>
                       </a:r>
                     </a:p>
                   </a:txBody>

</xml_diff>